<commit_message>
QA1 deck: QA4 module 기준 근거를 설계 component 수에서 OSS commit 규모 통계로 교체
Co-Authored-By: Claude Sonnet 5.5 <noreply@anthropic.com>
Claude-Session: https://claude.ai/code/session_01N1hDbMSeockiogwSqaDjq9
</commit_message>
<xml_diff>
--- a/doc-mk/Requirements/QA1-revised.pptx
+++ b/doc-mk/Requirements/QA1-revised.pptx
@@ -5960,7 +5960,7 @@
                       </a:r>
                       <a:r>
                         <a:rPr lang="en-US" altLang="ko-KR" sz="1000" b="1" dirty="0"/>
-                        <a:t>[측정: 변경 시나리오별 변경 모듈 ≤ 6개 (설계 component 12~14개의 절반 이하), 3종 중 최악값 기준]</a:t>
+                        <a:t>[측정: 변경 시나리오별 변경 모듈 ≤ 6개 (OSS commit의 80%가 6 file 이하), 3종 중 최악값 기준]</a:t>
                       </a:r>
                       <a:endParaRPr lang="ko-KR" altLang="en-US" sz="1000" dirty="0"/>
                     </a:p>
@@ -13417,327 +13417,7 @@
                 <a:latin typeface="맑은 고딕"/>
                 <a:ea typeface="맑은 고딕"/>
               </a:rPr>
-              <a:t>출처</a:t>
-            </a:r>
-            <a:r>
-              <a:rPr sz="750" b="0" dirty="0">
-                <a:solidFill>
-                  <a:srgbClr val="404040"/>
-                </a:solidFill>
-                <a:latin typeface="맑은 고딕"/>
-                <a:ea typeface="맑은 고딕"/>
-              </a:rPr>
-              <a:t>: </a:t>
-            </a:r>
-            <a:r>
-              <a:rPr lang="en-US" sz="750" b="0" dirty="0">
-                <a:solidFill>
-                  <a:srgbClr val="404040"/>
-                </a:solidFill>
-                <a:latin typeface="맑은 고딕"/>
-                <a:ea typeface="맑은 고딕"/>
-              </a:rPr>
-              <a:t>[1] </a:t>
-            </a:r>
-            <a:r>
-              <a:rPr sz="750" b="0" dirty="0">
-                <a:solidFill>
-                  <a:srgbClr val="404040"/>
-                </a:solidFill>
-                <a:latin typeface="맑은 고딕"/>
-                <a:ea typeface="맑은 고딕"/>
-              </a:rPr>
-              <a:t>SWE-bench (</a:t>
-            </a:r>
-            <a:r>
-              <a:rPr sz="750" b="0" dirty="0" err="1">
-                <a:solidFill>
-                  <a:srgbClr val="404040"/>
-                </a:solidFill>
-                <a:latin typeface="맑은 고딕"/>
-                <a:ea typeface="맑은 고딕"/>
-              </a:rPr>
-              <a:t>arXiv</a:t>
-            </a:r>
-            <a:r>
-              <a:rPr sz="750" b="0" dirty="0">
-                <a:solidFill>
-                  <a:srgbClr val="404040"/>
-                </a:solidFill>
-                <a:latin typeface="맑은 고딕"/>
-                <a:ea typeface="맑은 고딕"/>
-              </a:rPr>
-              <a:t> 2310.06770)</a:t>
-            </a:r>
-            <a:r>
-              <a:rPr lang="en-US" sz="750" b="0" dirty="0">
-                <a:solidFill>
-                  <a:srgbClr val="404040"/>
-                </a:solidFill>
-                <a:latin typeface="맑은 고딕"/>
-                <a:ea typeface="맑은 고딕"/>
-              </a:rPr>
-              <a:t>, </a:t>
-            </a:r>
-            <a:r>
-              <a:rPr lang="en-US" sz="750" dirty="0">
-                <a:solidFill>
-                  <a:srgbClr val="404040"/>
-                </a:solidFill>
-                <a:latin typeface="맑은 고딕"/>
-                <a:ea typeface="맑은 고딕"/>
-              </a:rPr>
-              <a:t>[2] </a:t>
-            </a:r>
-            <a:r>
-              <a:rPr sz="750" b="0" dirty="0" err="1">
-                <a:solidFill>
-                  <a:srgbClr val="404040"/>
-                </a:solidFill>
-                <a:latin typeface="맑은 고딕"/>
-                <a:ea typeface="맑은 고딕"/>
-              </a:rPr>
-              <a:t>vLLM</a:t>
-            </a:r>
-            <a:r>
-              <a:rPr sz="750" b="0" dirty="0">
-                <a:solidFill>
-                  <a:srgbClr val="404040"/>
-                </a:solidFill>
-                <a:latin typeface="맑은 고딕"/>
-                <a:ea typeface="맑은 고딕"/>
-              </a:rPr>
-              <a:t> </a:t>
-            </a:r>
-            <a:r>
-              <a:rPr sz="750" b="0" dirty="0" err="1">
-                <a:solidFill>
-                  <a:srgbClr val="404040"/>
-                </a:solidFill>
-                <a:latin typeface="맑은 고딕"/>
-                <a:ea typeface="맑은 고딕"/>
-              </a:rPr>
-              <a:t>저장소</a:t>
-            </a:r>
-            <a:r>
-              <a:rPr sz="750" b="0" dirty="0">
-                <a:solidFill>
-                  <a:srgbClr val="404040"/>
-                </a:solidFill>
-                <a:latin typeface="맑은 고딕"/>
-                <a:ea typeface="맑은 고딕"/>
-              </a:rPr>
-              <a:t> </a:t>
-            </a:r>
-            <a:r>
-              <a:rPr sz="750" b="0" dirty="0" err="1">
-                <a:solidFill>
-                  <a:srgbClr val="404040"/>
-                </a:solidFill>
-                <a:latin typeface="맑은 고딕"/>
-                <a:ea typeface="맑은 고딕"/>
-              </a:rPr>
-              <a:t>kv_connector</a:t>
-            </a:r>
-            <a:r>
-              <a:rPr sz="750" b="0" dirty="0">
-                <a:solidFill>
-                  <a:srgbClr val="404040"/>
-                </a:solidFill>
-                <a:latin typeface="맑은 고딕"/>
-                <a:ea typeface="맑은 고딕"/>
-              </a:rPr>
-              <a:t>/v1 </a:t>
-            </a:r>
-            <a:r>
-              <a:rPr sz="750" b="0" dirty="0" err="1">
-                <a:solidFill>
-                  <a:srgbClr val="404040"/>
-                </a:solidFill>
-                <a:latin typeface="맑은 고딕"/>
-                <a:ea typeface="맑은 고딕"/>
-              </a:rPr>
-              <a:t>직접</a:t>
-            </a:r>
-            <a:r>
-              <a:rPr sz="750" b="0" dirty="0">
-                <a:solidFill>
-                  <a:srgbClr val="404040"/>
-                </a:solidFill>
-                <a:latin typeface="맑은 고딕"/>
-                <a:ea typeface="맑은 고딕"/>
-              </a:rPr>
-              <a:t> </a:t>
-            </a:r>
-            <a:r>
-              <a:rPr sz="750" b="0" dirty="0" err="1">
-                <a:solidFill>
-                  <a:srgbClr val="404040"/>
-                </a:solidFill>
-                <a:latin typeface="맑은 고딕"/>
-                <a:ea typeface="맑은 고딕"/>
-              </a:rPr>
-              <a:t>계수</a:t>
-            </a:r>
-            <a:r>
-              <a:rPr sz="750" b="0" dirty="0">
-                <a:solidFill>
-                  <a:srgbClr val="404040"/>
-                </a:solidFill>
-                <a:latin typeface="맑은 고딕"/>
-                <a:ea typeface="맑은 고딕"/>
-              </a:rPr>
-              <a:t>(</a:t>
-            </a:r>
-            <a:r>
-              <a:rPr sz="750" b="0" dirty="0" err="1">
-                <a:solidFill>
-                  <a:srgbClr val="404040"/>
-                </a:solidFill>
-                <a:latin typeface="맑은 고딕"/>
-                <a:ea typeface="맑은 고딕"/>
-              </a:rPr>
-              <a:t>최상위</a:t>
-            </a:r>
-            <a:r>
-              <a:rPr sz="750" b="0" dirty="0">
-                <a:solidFill>
-                  <a:srgbClr val="404040"/>
-                </a:solidFill>
-                <a:latin typeface="맑은 고딕"/>
-                <a:ea typeface="맑은 고딕"/>
-              </a:rPr>
-              <a:t> </a:t>
-            </a:r>
-            <a:r>
-              <a:rPr sz="750" b="0" dirty="0" err="1">
-                <a:solidFill>
-                  <a:srgbClr val="404040"/>
-                </a:solidFill>
-                <a:latin typeface="맑은 고딕"/>
-                <a:ea typeface="맑은 고딕"/>
-              </a:rPr>
-              <a:t>파일</a:t>
-            </a:r>
-            <a:r>
-              <a:rPr sz="750" b="0" dirty="0">
-                <a:solidFill>
-                  <a:srgbClr val="404040"/>
-                </a:solidFill>
-                <a:latin typeface="맑은 고딕"/>
-                <a:ea typeface="맑은 고딕"/>
-              </a:rPr>
-              <a:t> 192~1,190 LOC, </a:t>
-            </a:r>
-            <a:r>
-              <a:rPr sz="750" b="0" dirty="0" err="1">
-                <a:solidFill>
-                  <a:srgbClr val="404040"/>
-                </a:solidFill>
-                <a:latin typeface="맑은 고딕"/>
-                <a:ea typeface="맑은 고딕"/>
-              </a:rPr>
-              <a:t>중앙값</a:t>
-            </a:r>
-            <a:r>
-              <a:rPr sz="750" b="0" dirty="0">
-                <a:solidFill>
-                  <a:srgbClr val="404040"/>
-                </a:solidFill>
-                <a:latin typeface="맑은 고딕"/>
-                <a:ea typeface="맑은 고딕"/>
-              </a:rPr>
-              <a:t> 356)</a:t>
-            </a:r>
-            <a:r>
-              <a:rPr lang="en-US" sz="750" b="0" dirty="0">
-                <a:solidFill>
-                  <a:srgbClr val="404040"/>
-                </a:solidFill>
-                <a:latin typeface="맑은 고딕"/>
-                <a:ea typeface="맑은 고딕"/>
-              </a:rPr>
-              <a:t>, </a:t>
-            </a:r>
-            <a:r>
-              <a:rPr lang="en-US" sz="750" dirty="0">
-                <a:solidFill>
-                  <a:srgbClr val="404040"/>
-                </a:solidFill>
-                <a:latin typeface="맑은 고딕"/>
-                <a:ea typeface="맑은 고딕"/>
-              </a:rPr>
-              <a:t>[3] </a:t>
-            </a:r>
-            <a:r>
-              <a:rPr lang="en-US" sz="750" b="0" dirty="0">
-                <a:solidFill>
-                  <a:srgbClr val="404040"/>
-                </a:solidFill>
-                <a:latin typeface="맑은 고딕"/>
-                <a:ea typeface="맑은 고딕"/>
-              </a:rPr>
-              <a:t>Brooks, The Mythical Man-Month </a:t>
-            </a:r>
-            <a:r>
-              <a:rPr lang="ko-KR" altLang="en-US" sz="750" b="0" dirty="0">
-                <a:solidFill>
-                  <a:srgbClr val="404040"/>
-                </a:solidFill>
-                <a:latin typeface="맑은 고딕"/>
-                <a:ea typeface="맑은 고딕"/>
-              </a:rPr>
-              <a:t>계열의 </a:t>
-            </a:r>
-            <a:r>
-              <a:rPr lang="en-US" altLang="ko-KR" sz="750" b="0" dirty="0">
-                <a:solidFill>
-                  <a:srgbClr val="404040"/>
-                </a:solidFill>
-                <a:latin typeface="맑은 고딕"/>
-                <a:ea typeface="맑은 고딕"/>
-              </a:rPr>
-              <a:t>"</a:t>
-            </a:r>
-            <a:r>
-              <a:rPr lang="ko-KR" altLang="en-US" sz="750" b="0" dirty="0">
-                <a:solidFill>
-                  <a:srgbClr val="404040"/>
-                </a:solidFill>
-                <a:latin typeface="맑은 고딕"/>
-                <a:ea typeface="맑은 고딕"/>
-              </a:rPr>
-              <a:t>하루 약 </a:t>
-            </a:r>
-            <a:r>
-              <a:rPr lang="en-US" altLang="ko-KR" sz="750" b="0" dirty="0">
-                <a:solidFill>
-                  <a:srgbClr val="404040"/>
-                </a:solidFill>
-                <a:latin typeface="맑은 고딕"/>
-                <a:ea typeface="맑은 고딕"/>
-              </a:rPr>
-              <a:t>10 </a:t>
-            </a:r>
-            <a:r>
-              <a:rPr lang="en-US" sz="750" b="0" dirty="0">
-                <a:solidFill>
-                  <a:srgbClr val="404040"/>
-                </a:solidFill>
-                <a:latin typeface="맑은 고딕"/>
-                <a:ea typeface="맑은 고딕"/>
-              </a:rPr>
-              <a:t>LOC“, </a:t>
-            </a:r>
-            <a:r>
-              <a:rPr lang="sv-SE" sz="750" b="0" dirty="0">
-                <a:solidFill>
-                  <a:srgbClr val="404040"/>
-                </a:solidFill>
-                <a:latin typeface="맑은 고딕"/>
-                <a:ea typeface="맑은 고딕"/>
-              </a:rPr>
-              <a:t>Poul-Henning Kamp (Varnish), “Going fast slowly”</a:t>
+              <a:t>출처: [1] SWE-bench (arXiv 2310.06770), [2] vLLM 저장소 kv_connector/v1 직접 계수(최상위 파일 192~1,190 LOC, 중앙값 356), [3] Brooks, The Mythical Man-Month 계열의 "하루 약 10 LOC“, Poul-Henning Kamp (Varnish), “Going fast slowly” [4] Ferreira et al., Characterizing Commits in Open-Source Software, SBQS 2022 (Java 24개 프로젝트, 1M commits). file 수는 module 수의 상한 근사(module ≥ 1 file)</a:t>
             </a:r>
             <a:endParaRPr sz="750" b="0" dirty="0">
               <a:solidFill>
@@ -14691,7 +14371,7 @@
                           <a:latin typeface="맑은 고딕"/>
                           <a:ea typeface="맑은 고딕"/>
                         </a:rPr>
-                        <a:t>일상 변경 규모: </a:t>
+                        <a:t>일상 변경 규모(중앙값): OSS Java 24개 프로젝트 files/commit 중앙값 1~3 (다수 2)</a:t>
                       </a:r>
                       <a:endParaRPr lang="en-US" sz="900" b="1" dirty="0">
                         <a:solidFill>
@@ -14763,27 +14443,7 @@
                           <a:latin typeface="맑은 고딕"/>
                           <a:ea typeface="맑은 고딕"/>
                         </a:rPr>
-                        <a:t>SWE-bench (</a:t>
-                      </a:r>
-                      <a:r>
-                        <a:rPr sz="900" b="0" dirty="0" err="1">
-                          <a:solidFill>
-                            <a:srgbClr val="000000"/>
-                          </a:solidFill>
-                          <a:latin typeface="맑은 고딕"/>
-                          <a:ea typeface="맑은 고딕"/>
-                        </a:rPr>
-                        <a:t>arXiv</a:t>
-                      </a:r>
-                      <a:r>
-                        <a:rPr sz="900" b="0" dirty="0">
-                          <a:solidFill>
-                            <a:srgbClr val="000000"/>
-                          </a:solidFill>
-                          <a:latin typeface="맑은 고딕"/>
-                          <a:ea typeface="맑은 고딕"/>
-                        </a:rPr>
-                        <a:t> 2310.06770), </a:t>
+                        <a:t>Ferreira et al. [4],</a:t>
                       </a:r>
                       <a:endParaRPr lang="en-US" sz="900" b="0" dirty="0">
                         <a:solidFill>
@@ -14807,47 +14467,7 @@
                           <a:latin typeface="맑은 고딕"/>
                           <a:ea typeface="맑은 고딕"/>
                         </a:rPr>
-                        <a:t>사전</a:t>
-                      </a:r>
-                      <a:r>
-                        <a:rPr sz="900" b="0" dirty="0">
-                          <a:solidFill>
-                            <a:srgbClr val="000000"/>
-                          </a:solidFill>
-                          <a:latin typeface="맑은 고딕"/>
-                          <a:ea typeface="맑은 고딕"/>
-                        </a:rPr>
-                        <a:t> </a:t>
-                      </a:r>
-                      <a:r>
-                        <a:rPr sz="900" b="0" dirty="0" err="1">
-                          <a:solidFill>
-                            <a:srgbClr val="000000"/>
-                          </a:solidFill>
-                          <a:latin typeface="맑은 고딕"/>
-                          <a:ea typeface="맑은 고딕"/>
-                        </a:rPr>
-                        <a:t>등록</a:t>
-                      </a:r>
-                      <a:r>
-                        <a:rPr sz="900" b="0" dirty="0">
-                          <a:solidFill>
-                            <a:srgbClr val="000000"/>
-                          </a:solidFill>
-                          <a:latin typeface="맑은 고딕"/>
-                          <a:ea typeface="맑은 고딕"/>
-                        </a:rPr>
-                        <a:t> </a:t>
-                      </a:r>
-                      <a:r>
-                        <a:rPr sz="900" b="0" dirty="0" err="1">
-                          <a:solidFill>
-                            <a:srgbClr val="000000"/>
-                          </a:solidFill>
-                          <a:latin typeface="맑은 고딕"/>
-                          <a:ea typeface="맑은 고딕"/>
-                        </a:rPr>
-                        <a:t>가정</a:t>
+                        <a:t>SWE-bench (arXiv 2310.06770)</a:t>
                       </a:r>
                       <a:endParaRPr sz="900" b="0" dirty="0">
                         <a:solidFill>
@@ -15277,7 +14897,7 @@
                       </a:pPr>
                       <a:r>
                         <a:rPr lang="ko-KR" altLang="en-US" sz="900" b="1" dirty="0"/>
-                        <a:t>변경이 한 Plane 안에서 끝남: component 12~14개 ÷ 3 Plane(Decision·Control·Data) ≈ 4개</a:t>
+                        <a:t>★1과 ★3의 산술 중점 (기존 별 규칙: ★★ = ★과 ★★★의 중점)</a:t>
                       </a:r>
                       <a:endParaRPr sz="900" b="1" dirty="0">
                         <a:solidFill>
@@ -15519,7 +15139,7 @@
                           <a:latin typeface="맑은 고딕"/>
                           <a:ea typeface="맑은 고딕"/>
                         </a:rPr>
-                        <a:t>★1과 ★2의 중점 (정수 module 수 기준)</a:t>
+                        <a:t>★1과 ★2의 중점. 참고: commit의 75%가 5 file 이하 (24개 프로젝트 Q3의 중앙값)</a:t>
                       </a:r>
                       <a:endParaRPr sz="900" b="0" dirty="0">
                         <a:solidFill>
@@ -15574,7 +15194,7 @@
                           <a:latin typeface="맑은 고딕"/>
                           <a:ea typeface="맑은 고딕"/>
                         </a:rPr>
-                        <a:t>—</a:t>
+                        <a:t>Ferreira et al. [4]</a:t>
                       </a:r>
                     </a:p>
                   </a:txBody>
@@ -15755,7 +15375,7 @@
                       </a:pPr>
                       <a:r>
                         <a:rPr lang="ko-KR" altLang="en-US" sz="900" b="1" dirty="0"/>
-                        <a:t>최소 충족선: 한 번의 변경이 설계 component의 절반 이하에 국한된다.</a:t>
+                        <a:t>최소 충족선: 일상 변경의 80%가 이 규모 이하.</a:t>
                       </a:r>
                     </a:p>
                     <a:p>
@@ -15766,7 +15386,7 @@
                       </a:pPr>
                       <a:r>
                         <a:rPr lang="ko-KR" altLang="en-US" sz="900" b="1" dirty="0"/>
-                        <a:t>component 12~14개의 1/2 ≈ 6개 (과반을 건드리지 않음).</a:t>
+                        <a:t>OSS Java 24개 프로젝트 files/commit 80th percentile의 중앙값 6 (범위 2~15).</a:t>
                       </a:r>
                     </a:p>
                   </a:txBody>
@@ -15814,7 +15434,7 @@
                           <a:latin typeface="맑은 고딕"/>
                           <a:ea typeface="맑은 고딕"/>
                         </a:rPr>
-                        <a:t>DP1 사전 등록 component 목록,</a:t>
+                        <a:t>Ferreira et al. [4]</a:t>
                       </a:r>
                       <a:endParaRPr lang="en-US" sz="900" b="0" dirty="0">
                         <a:solidFill>
@@ -15838,7 +15458,7 @@
                           <a:latin typeface="맑은 고딕"/>
                           <a:ea typeface="맑은 고딕"/>
                         </a:rPr>
-                        <a:t>3-Plane 구성(Decision·Control·Data)</a:t>
+                        <a:t>(SBQS 2022, Table 4)</a:t>
                       </a:r>
                       <a:endParaRPr sz="900" b="0" dirty="0">
                         <a:solidFill>
@@ -16038,7 +15658,7 @@
                       </a:pPr>
                       <a:r>
                         <a:rPr lang="en-US" altLang="ko-KR" sz="900" dirty="0"/>
-                        <a:t>7개 이상이면 한 번의 변경이 설계의 과반으로 퍼져 확장 지점이 없는 구조로 판단.</a:t>
+                        <a:t>7개 이상이면 일상 변경 상위 20%에 해당하는 큰 변경 규모: 확장 지점이 없는 구조로 판단.</a:t>
                       </a:r>
                       <a:endParaRPr sz="900" b="0" dirty="0">
                         <a:solidFill>
@@ -18542,7 +18162,7 @@
         <p:spPr>
           <a:xfrm>
             <a:off x="5344016" y="5835777"/>
-            <a:ext cx="3080000" cy="182880"/>
+            <a:ext cx="2500000" cy="182880"/>
           </a:xfrm>
           <a:prstGeom prst="rect">
             <a:avLst/>
@@ -18568,7 +18188,7 @@
                 <a:latin typeface="맑은 고딕"/>
                 <a:ea typeface="맑은 고딕"/>
               </a:rPr>
-              <a:t>★2 경계 4 module ≈ 0.8 MM · component 12~14개 ÷ 3 Plane ≈ 4개</a:t>
+              <a:t>★2 경계 4 module ≈ 0.8 MM · ★1과 ★3의 중점</a:t>
             </a:r>
           </a:p>
         </p:txBody>
@@ -18639,7 +18259,7 @@
         <p:spPr>
           <a:xfrm>
             <a:off x="2104428" y="6018657"/>
-            <a:ext cx="3429000" cy="182880"/>
+            <a:ext cx="3600000" cy="182880"/>
           </a:xfrm>
           <a:prstGeom prst="rect">
             <a:avLst/>
@@ -18665,7 +18285,7 @@
                 <a:latin typeface="맑은 고딕"/>
                 <a:ea typeface="맑은 고딕"/>
               </a:rPr>
-              <a:t>★1 경계 6 module ≈ 1.2 MM · component 12~14개의 1/2</a:t>
+              <a:t>★1 경계 6 module ≈ 1.2 MM · 일상 변경의 80% (OSS commit 80th %ile 중앙값)</a:t>
             </a:r>
           </a:p>
         </p:txBody>

</xml_diff>

<commit_message>
QA1 deck: QA4 변경 시나리오를 4종(새 tier·data class, 정책, upstream, 새 event·신호)으로 확장
Co-Authored-By: Claude Sonnet 5.5 <noreply@anthropic.com>
Claude-Session: https://claude.ai/code/session_01N1hDbMSeockiogwSqaDjq9
</commit_message>
<xml_diff>
--- a/doc-mk/Requirements/QA1-revised.pptx
+++ b/doc-mk/Requirements/QA1-revised.pptx
@@ -5956,11 +5956,11 @@
                       </a:br>
                       <a:r>
                         <a:rPr lang="ko-KR" altLang="en-US" sz="1000" dirty="0"/>
-                        <a:t>새로운 메모리 tier 추가, 이동·배치 정책 교체, Upstream(vLLM) 변경은 각각 단독으로 발생할 수 있다. 어느 경우든 서빙 경로에 미치는 변경 범위를 최소화하여 반영할 수 있어야 한다. </a:t>
+                        <a:t>새로운 메모리 tier 추가, 이동·배치 정책 교체, Upstream(vLLM) 변경, 새 event·telemetry 신호 추가는 각각 단독으로 발생할 수 있다. 어느 경우든 서빙 경로에 미치는 변경 범위를 최소화하여 반영할 수 있어야 한다. </a:t>
                       </a:r>
                       <a:r>
                         <a:rPr lang="en-US" altLang="ko-KR" sz="1000" b="1" dirty="0"/>
-                        <a:t>[측정: 변경 시나리오별 변경 모듈 ≤ 6개 (OSS commit의 80%가 6 file 이하), 3종 중 최악값 기준]</a:t>
+                        <a:t>[측정: 변경 시나리오별 변경 모듈 ≤ 6개 (OSS commit의 80%가 6 file 이하), 4종 중 최악값 기준]</a:t>
                       </a:r>
                       <a:endParaRPr lang="ko-KR" altLang="en-US" sz="1000" dirty="0"/>
                     </a:p>
@@ -13473,367 +13473,17 @@
                 <a:latin typeface="맑은 고딕"/>
                 <a:ea typeface="맑은 고딕"/>
               </a:rPr>
-              <a:t>[</a:t>
-            </a:r>
-            <a:r>
-              <a:rPr sz="1000" b="1" dirty="0" err="1">
-                <a:solidFill>
-                  <a:srgbClr val="2F5597"/>
-                </a:solidFill>
-                <a:latin typeface="맑은 고딕"/>
-                <a:ea typeface="맑은 고딕"/>
-              </a:rPr>
-              <a:t>변경</a:t>
-            </a:r>
-            <a:r>
-              <a:rPr sz="1000" b="1" dirty="0">
-                <a:solidFill>
-                  <a:srgbClr val="2F5597"/>
-                </a:solidFill>
-                <a:latin typeface="맑은 고딕"/>
-                <a:ea typeface="맑은 고딕"/>
-              </a:rPr>
-              <a:t> </a:t>
-            </a:r>
-            <a:r>
-              <a:rPr sz="1000" b="1" dirty="0" err="1">
-                <a:solidFill>
-                  <a:srgbClr val="2F5597"/>
-                </a:solidFill>
-                <a:latin typeface="맑은 고딕"/>
-                <a:ea typeface="맑은 고딕"/>
-              </a:rPr>
-              <a:t>시나리오</a:t>
-            </a:r>
-            <a:r>
-              <a:rPr sz="1000" b="1" dirty="0">
-                <a:solidFill>
-                  <a:srgbClr val="2F5597"/>
-                </a:solidFill>
-                <a:latin typeface="맑은 고딕"/>
-                <a:ea typeface="맑은 고딕"/>
-              </a:rPr>
-              <a:t> 3종, KV </a:t>
-            </a:r>
-            <a:r>
-              <a:rPr sz="1000" b="1" dirty="0" err="1">
-                <a:solidFill>
-                  <a:srgbClr val="2F5597"/>
-                </a:solidFill>
-                <a:latin typeface="맑은 고딕"/>
-                <a:ea typeface="맑은 고딕"/>
-              </a:rPr>
-              <a:t>캐시</a:t>
-            </a:r>
-            <a:r>
-              <a:rPr sz="1000" b="1" dirty="0">
-                <a:solidFill>
-                  <a:srgbClr val="2F5597"/>
-                </a:solidFill>
-                <a:latin typeface="맑은 고딕"/>
-                <a:ea typeface="맑은 고딕"/>
-              </a:rPr>
-              <a:t> </a:t>
-            </a:r>
-            <a:r>
-              <a:rPr sz="1000" b="1" dirty="0" err="1">
-                <a:solidFill>
-                  <a:srgbClr val="2F5597"/>
-                </a:solidFill>
-                <a:latin typeface="맑은 고딕"/>
-                <a:ea typeface="맑은 고딕"/>
-              </a:rPr>
-              <a:t>관리</a:t>
-            </a:r>
-            <a:r>
-              <a:rPr sz="1000" b="1" dirty="0">
-                <a:solidFill>
-                  <a:srgbClr val="2F5597"/>
-                </a:solidFill>
-                <a:latin typeface="맑은 고딕"/>
-                <a:ea typeface="맑은 고딕"/>
-              </a:rPr>
-              <a:t> </a:t>
-            </a:r>
-            <a:r>
-              <a:rPr sz="1000" b="1" dirty="0" err="1">
-                <a:solidFill>
-                  <a:srgbClr val="2F5597"/>
-                </a:solidFill>
-                <a:latin typeface="맑은 고딕"/>
-                <a:ea typeface="맑은 고딕"/>
-              </a:rPr>
-              <a:t>범위</a:t>
-            </a:r>
-            <a:r>
-              <a:rPr sz="1000" b="1" dirty="0">
-                <a:solidFill>
-                  <a:srgbClr val="2F5597"/>
-                </a:solidFill>
-                <a:latin typeface="맑은 고딕"/>
-                <a:ea typeface="맑은 고딕"/>
-              </a:rPr>
-              <a:t>] </a:t>
-            </a:r>
-            <a:r>
-              <a:rPr lang="en-US" sz="950" b="1" dirty="0">
+              <a:t>[변경 시나리오 4종, KV 캐시 관리 범위] </a:t>
+            </a:r>
+            <a:r>
+              <a:rPr sz="950" b="0" dirty="0">
                 <a:solidFill>
                   <a:srgbClr val="000000"/>
                 </a:solidFill>
                 <a:latin typeface="맑은 고딕"/>
                 <a:ea typeface="맑은 고딕"/>
               </a:rPr>
-              <a:t>S</a:t>
-            </a:r>
-            <a:r>
-              <a:rPr sz="950" b="0" dirty="0">
-                <a:solidFill>
-                  <a:srgbClr val="000000"/>
-                </a:solidFill>
-                <a:latin typeface="맑은 고딕"/>
-                <a:ea typeface="맑은 고딕"/>
-              </a:rPr>
-              <a:t>1 새 </a:t>
-            </a:r>
-            <a:r>
-              <a:rPr sz="950" b="0" dirty="0" err="1">
-                <a:solidFill>
-                  <a:srgbClr val="000000"/>
-                </a:solidFill>
-                <a:latin typeface="맑은 고딕"/>
-                <a:ea typeface="맑은 고딕"/>
-              </a:rPr>
-              <a:t>메모리</a:t>
-            </a:r>
-            <a:r>
-              <a:rPr sz="950" b="0" dirty="0">
-                <a:solidFill>
-                  <a:srgbClr val="000000"/>
-                </a:solidFill>
-                <a:latin typeface="맑은 고딕"/>
-                <a:ea typeface="맑은 고딕"/>
-              </a:rPr>
-              <a:t> tier </a:t>
-            </a:r>
-            <a:r>
-              <a:rPr sz="950" b="0" dirty="0" err="1">
-                <a:solidFill>
-                  <a:srgbClr val="000000"/>
-                </a:solidFill>
-                <a:latin typeface="맑은 고딕"/>
-                <a:ea typeface="맑은 고딕"/>
-              </a:rPr>
-              <a:t>추가</a:t>
-            </a:r>
-            <a:r>
-              <a:rPr lang="en-US" sz="950" dirty="0">
-                <a:solidFill>
-                  <a:srgbClr val="000000"/>
-                </a:solidFill>
-                <a:latin typeface="맑은 고딕"/>
-                <a:ea typeface="맑은 고딕"/>
-              </a:rPr>
-              <a:t>, </a:t>
-            </a:r>
-            <a:r>
-              <a:rPr sz="950" b="0" dirty="0">
-                <a:solidFill>
-                  <a:srgbClr val="000000"/>
-                </a:solidFill>
-                <a:latin typeface="맑은 고딕"/>
-                <a:ea typeface="맑은 고딕"/>
-              </a:rPr>
-              <a:t>S2 </a:t>
-            </a:r>
-            <a:r>
-              <a:rPr sz="950" b="0" dirty="0" err="1">
-                <a:solidFill>
-                  <a:srgbClr val="000000"/>
-                </a:solidFill>
-                <a:latin typeface="맑은 고딕"/>
-                <a:ea typeface="맑은 고딕"/>
-              </a:rPr>
-              <a:t>이동·배치·재사용</a:t>
-            </a:r>
-            <a:r>
-              <a:rPr sz="950" b="0" dirty="0">
-                <a:solidFill>
-                  <a:srgbClr val="000000"/>
-                </a:solidFill>
-                <a:latin typeface="맑은 고딕"/>
-                <a:ea typeface="맑은 고딕"/>
-              </a:rPr>
-              <a:t> </a:t>
-            </a:r>
-            <a:r>
-              <a:rPr sz="950" b="0" dirty="0" err="1">
-                <a:solidFill>
-                  <a:srgbClr val="000000"/>
-                </a:solidFill>
-                <a:latin typeface="맑은 고딕"/>
-                <a:ea typeface="맑은 고딕"/>
-              </a:rPr>
-              <a:t>정책</a:t>
-            </a:r>
-            <a:r>
-              <a:rPr sz="950" b="0" dirty="0">
-                <a:solidFill>
-                  <a:srgbClr val="000000"/>
-                </a:solidFill>
-                <a:latin typeface="맑은 고딕"/>
-                <a:ea typeface="맑은 고딕"/>
-              </a:rPr>
-              <a:t> </a:t>
-            </a:r>
-            <a:r>
-              <a:rPr sz="950" b="0" dirty="0" err="1">
-                <a:solidFill>
-                  <a:srgbClr val="000000"/>
-                </a:solidFill>
-                <a:latin typeface="맑은 고딕"/>
-                <a:ea typeface="맑은 고딕"/>
-              </a:rPr>
-              <a:t>교체</a:t>
-            </a:r>
-            <a:r>
-              <a:rPr lang="en-US" sz="950" dirty="0">
-                <a:solidFill>
-                  <a:srgbClr val="000000"/>
-                </a:solidFill>
-                <a:latin typeface="맑은 고딕"/>
-                <a:ea typeface="맑은 고딕"/>
-              </a:rPr>
-              <a:t>, </a:t>
-            </a:r>
-            <a:r>
-              <a:rPr lang="en-US" altLang="ko-KR" sz="950" dirty="0">
-                <a:solidFill>
-                  <a:srgbClr val="000000"/>
-                </a:solidFill>
-                <a:latin typeface="맑은 고딕"/>
-                <a:ea typeface="맑은 고딕"/>
-              </a:rPr>
-              <a:t>S3 </a:t>
-            </a:r>
-            <a:r>
-              <a:rPr sz="950" b="0" dirty="0" err="1">
-                <a:solidFill>
-                  <a:srgbClr val="000000"/>
-                </a:solidFill>
-                <a:latin typeface="맑은 고딕"/>
-                <a:ea typeface="맑은 고딕"/>
-              </a:rPr>
-              <a:t>vLLM</a:t>
-            </a:r>
-            <a:r>
-              <a:rPr sz="950" b="0" dirty="0">
-                <a:solidFill>
-                  <a:srgbClr val="000000"/>
-                </a:solidFill>
-                <a:latin typeface="맑은 고딕"/>
-                <a:ea typeface="맑은 고딕"/>
-              </a:rPr>
-              <a:t> upstream </a:t>
-            </a:r>
-            <a:r>
-              <a:rPr sz="950" b="0" dirty="0" err="1">
-                <a:solidFill>
-                  <a:srgbClr val="000000"/>
-                </a:solidFill>
-                <a:latin typeface="맑은 고딕"/>
-                <a:ea typeface="맑은 고딕"/>
-              </a:rPr>
-              <a:t>갱신</a:t>
-            </a:r>
-            <a:r>
-              <a:rPr sz="950" b="0" dirty="0">
-                <a:solidFill>
-                  <a:srgbClr val="000000"/>
-                </a:solidFill>
-                <a:latin typeface="맑은 고딕"/>
-                <a:ea typeface="맑은 고딕"/>
-              </a:rPr>
-              <a:t> </a:t>
-            </a:r>
-            <a:r>
-              <a:rPr sz="950" b="0" dirty="0" err="1">
-                <a:solidFill>
-                  <a:srgbClr val="000000"/>
-                </a:solidFill>
-                <a:latin typeface="맑은 고딕"/>
-                <a:ea typeface="맑은 고딕"/>
-              </a:rPr>
-              <a:t>대응</a:t>
-            </a:r>
-            <a:r>
-              <a:rPr sz="950" b="0" dirty="0">
-                <a:solidFill>
-                  <a:srgbClr val="000000"/>
-                </a:solidFill>
-                <a:latin typeface="맑은 고딕"/>
-                <a:ea typeface="맑은 고딕"/>
-              </a:rPr>
-              <a:t>(block pool, </a:t>
-            </a:r>
-            <a:r>
-              <a:rPr sz="950" b="0" dirty="0" err="1">
-                <a:solidFill>
-                  <a:srgbClr val="000000"/>
-                </a:solidFill>
-                <a:latin typeface="맑은 고딕"/>
-                <a:ea typeface="맑은 고딕"/>
-              </a:rPr>
-              <a:t>kv_offload</a:t>
-            </a:r>
-            <a:r>
-              <a:rPr sz="950" b="0" dirty="0">
-                <a:solidFill>
-                  <a:srgbClr val="000000"/>
-                </a:solidFill>
-                <a:latin typeface="맑은 고딕"/>
-                <a:ea typeface="맑은 고딕"/>
-              </a:rPr>
-              <a:t>, CUDA graph, async scheduling </a:t>
-            </a:r>
-            <a:r>
-              <a:rPr sz="950" b="0" dirty="0" err="1">
-                <a:solidFill>
-                  <a:srgbClr val="000000"/>
-                </a:solidFill>
-                <a:latin typeface="맑은 고딕"/>
-                <a:ea typeface="맑은 고딕"/>
-              </a:rPr>
-              <a:t>접점</a:t>
-            </a:r>
-            <a:r>
-              <a:rPr sz="950" b="0" dirty="0">
-                <a:solidFill>
-                  <a:srgbClr val="000000"/>
-                </a:solidFill>
-                <a:latin typeface="맑은 고딕"/>
-                <a:ea typeface="맑은 고딕"/>
-              </a:rPr>
-              <a:t> </a:t>
-            </a:r>
-            <a:r>
-              <a:rPr sz="950" b="0" dirty="0" err="1">
-                <a:solidFill>
-                  <a:srgbClr val="000000"/>
-                </a:solidFill>
-                <a:latin typeface="맑은 고딕"/>
-                <a:ea typeface="맑은 고딕"/>
-              </a:rPr>
-              <a:t>수정</a:t>
-            </a:r>
-            <a:r>
-              <a:rPr sz="950" b="0" dirty="0">
-                <a:solidFill>
-                  <a:srgbClr val="000000"/>
-                </a:solidFill>
-                <a:latin typeface="맑은 고딕"/>
-                <a:ea typeface="맑은 고딕"/>
-              </a:rPr>
-              <a:t>). </a:t>
+              <a:t>S1 새 tier·data class, S2 정책 교체, S3 vLLM upstream 갱신(block pool, kv_offload, CUDA graph, async scheduling), S4 새 event·신호. </a:t>
             </a:r>
             <a:endParaRPr lang="en-US" sz="950" b="0" dirty="0">
               <a:solidFill>
@@ -13860,7 +13510,7 @@
                 <a:latin typeface="맑은 고딕"/>
                 <a:ea typeface="맑은 고딕"/>
               </a:rPr>
-              <a:t>세 변경은 각각 단독 발생하므로 시나리오별로 판정하고 3종 중 최악값(최대 module 수)에 별 기준을 적용한다(평균 안 씀). module = 설계 component 단위(한 줄이라도 바꾸면 1개).</a:t>
+              <a:t>네 변경은 각각 단독 발생하므로 시나리오별로 판정, 4종 중 최악값(최대 module 수)에 별 기준 적용(평균 안 씀). module = 설계 component 단위(한 줄이라도 바꾸면 1개).</a:t>
             </a:r>
           </a:p>
         </p:txBody>

</xml_diff>